<commit_message>
Add market context chart and update outputs
- Add market data fetching for TGT vs S&P 500 comparison
- Add market context visualization (chart_market_context)
- Update all chart HTML/PNG outputs with latest data
- Regenerate PowerPoint presentations with file:// URI fix
- Add peer filings data and market data cache

Co-Authored-By: Claude Opus 4.5 <noreply@anthropic.com>
</commit_message>
<xml_diff>
--- a/output/Target_Executive_Presentation.pptx
+++ b/output/Target_Executive_Presentation.pptx
@@ -3310,9 +3310,42 @@
           </a:p>
         </p:txBody>
       </p:sp>
+      <p:sp>
+        <p:nvSpPr>
+          <p:cNvPr id="3" name="TextBox 2"/>
+          <p:cNvSpPr txBox="1"/>
+          <p:nvPr/>
+        </p:nvSpPr>
+        <p:spPr>
+          <a:xfrm>
+            <a:off x="8229600" y="228600"/>
+            <a:ext cx="365760" cy="365760"/>
+          </a:xfrm>
+          <a:prstGeom prst="rect">
+            <a:avLst/>
+          </a:prstGeom>
+          <a:noFill/>
+        </p:spPr>
+        <p:txBody>
+          <a:bodyPr wrap="none">
+            <a:spAutoFit/>
+          </a:bodyPr>
+          <a:lstStyle/>
+          <a:p>
+            <a:r>
+              <a:rPr sz="1800">
+                <a:solidFill>
+                  <a:srgbClr val="646464"/>
+                </a:solidFill>
+              </a:rPr>
+              <a:t>ⓘ</a:t>
+            </a:r>
+          </a:p>
+        </p:txBody>
+      </p:sp>
       <p:pic>
         <p:nvPicPr>
-          <p:cNvPr id="3" name="Picture 2" descr="chart_inventory_efficiency.png"/>
+          <p:cNvPr id="4" name="Picture 3" descr="chart_inventory_efficiency.png"/>
           <p:cNvPicPr>
             <a:picLocks noChangeAspect="1"/>
           </p:cNvPicPr>
@@ -3336,7 +3369,7 @@
       </p:pic>
       <p:sp>
         <p:nvSpPr>
-          <p:cNvPr id="4" name="TextBox 3"/>
+          <p:cNvPr id="5" name="TextBox 4"/>
           <p:cNvSpPr txBox="1"/>
           <p:nvPr/>
         </p:nvSpPr>
@@ -3357,9 +3390,9 @@
           <a:lstStyle/>
           <a:p>
             <a:pPr>
-              <a:defRPr sz="1200">
-                <a:solidFill>
-                  <a:srgbClr val="646464"/>
+              <a:defRPr sz="1200" b="1">
+                <a:solidFill>
+                  <a:srgbClr val="323232"/>
                 </a:solidFill>
               </a:defRPr>
             </a:pPr>
@@ -3371,7 +3404,7 @@
       </p:sp>
       <p:sp>
         <p:nvSpPr>
-          <p:cNvPr id="5" name="TextBox 4"/>
+          <p:cNvPr id="6" name="TextBox 5"/>
           <p:cNvSpPr txBox="1"/>
           <p:nvPr/>
         </p:nvSpPr>
@@ -4024,9 +4057,42 @@
           </a:p>
         </p:txBody>
       </p:sp>
+      <p:sp>
+        <p:nvSpPr>
+          <p:cNvPr id="3" name="TextBox 2"/>
+          <p:cNvSpPr txBox="1"/>
+          <p:nvPr/>
+        </p:nvSpPr>
+        <p:spPr>
+          <a:xfrm>
+            <a:off x="8229600" y="228600"/>
+            <a:ext cx="365760" cy="365760"/>
+          </a:xfrm>
+          <a:prstGeom prst="rect">
+            <a:avLst/>
+          </a:prstGeom>
+          <a:noFill/>
+        </p:spPr>
+        <p:txBody>
+          <a:bodyPr wrap="none">
+            <a:spAutoFit/>
+          </a:bodyPr>
+          <a:lstStyle/>
+          <a:p>
+            <a:r>
+              <a:rPr sz="1800">
+                <a:solidFill>
+                  <a:srgbClr val="646464"/>
+                </a:solidFill>
+              </a:rPr>
+              <a:t>ⓘ</a:t>
+            </a:r>
+          </a:p>
+        </p:txBody>
+      </p:sp>
       <p:pic>
         <p:nvPicPr>
-          <p:cNvPr id="3" name="Picture 2" descr="chart_valuation_scatter.png"/>
+          <p:cNvPr id="4" name="Picture 3" descr="chart_valuation_scatter.png"/>
           <p:cNvPicPr>
             <a:picLocks noChangeAspect="1"/>
           </p:cNvPicPr>
@@ -4050,7 +4116,7 @@
       </p:pic>
       <p:sp>
         <p:nvSpPr>
-          <p:cNvPr id="4" name="TextBox 3"/>
+          <p:cNvPr id="5" name="TextBox 4"/>
           <p:cNvSpPr txBox="1"/>
           <p:nvPr/>
         </p:nvSpPr>
@@ -4071,9 +4137,9 @@
           <a:lstStyle/>
           <a:p>
             <a:pPr>
-              <a:defRPr sz="1200">
-                <a:solidFill>
-                  <a:srgbClr val="646464"/>
+              <a:defRPr sz="1200" b="1">
+                <a:solidFill>
+                  <a:srgbClr val="323232"/>
                 </a:solidFill>
               </a:defRPr>
             </a:pPr>
@@ -4085,7 +4151,7 @@
       </p:sp>
       <p:sp>
         <p:nvSpPr>
-          <p:cNvPr id="5" name="TextBox 4"/>
+          <p:cNvPr id="6" name="TextBox 5"/>
           <p:cNvSpPr txBox="1"/>
           <p:nvPr/>
         </p:nvSpPr>
@@ -4170,9 +4236,42 @@
           </a:p>
         </p:txBody>
       </p:sp>
+      <p:sp>
+        <p:nvSpPr>
+          <p:cNvPr id="3" name="TextBox 2"/>
+          <p:cNvSpPr txBox="1"/>
+          <p:nvPr/>
+        </p:nvSpPr>
+        <p:spPr>
+          <a:xfrm>
+            <a:off x="8229600" y="228600"/>
+            <a:ext cx="365760" cy="365760"/>
+          </a:xfrm>
+          <a:prstGeom prst="rect">
+            <a:avLst/>
+          </a:prstGeom>
+          <a:noFill/>
+        </p:spPr>
+        <p:txBody>
+          <a:bodyPr wrap="none">
+            <a:spAutoFit/>
+          </a:bodyPr>
+          <a:lstStyle/>
+          <a:p>
+            <a:r>
+              <a:rPr sz="1800">
+                <a:solidFill>
+                  <a:srgbClr val="646464"/>
+                </a:solidFill>
+              </a:rPr>
+              <a:t>ⓘ</a:t>
+            </a:r>
+          </a:p>
+        </p:txBody>
+      </p:sp>
       <p:pic>
         <p:nvPicPr>
-          <p:cNvPr id="3" name="Picture 2" descr="chart_risk_heatmap_grid.png"/>
+          <p:cNvPr id="4" name="Picture 3" descr="chart_risk_heatmap_grid.png"/>
           <p:cNvPicPr>
             <a:picLocks noChangeAspect="1"/>
           </p:cNvPicPr>
@@ -4196,7 +4295,7 @@
       </p:pic>
       <p:sp>
         <p:nvSpPr>
-          <p:cNvPr id="4" name="TextBox 3"/>
+          <p:cNvPr id="5" name="TextBox 4"/>
           <p:cNvSpPr txBox="1"/>
           <p:nvPr/>
         </p:nvSpPr>
@@ -4217,9 +4316,9 @@
           <a:lstStyle/>
           <a:p>
             <a:pPr>
-              <a:defRPr sz="1200">
-                <a:solidFill>
-                  <a:srgbClr val="646464"/>
+              <a:defRPr sz="1200" b="1">
+                <a:solidFill>
+                  <a:srgbClr val="323232"/>
                 </a:solidFill>
               </a:defRPr>
             </a:pPr>
@@ -4231,7 +4330,7 @@
       </p:sp>
       <p:sp>
         <p:nvSpPr>
-          <p:cNvPr id="5" name="TextBox 4"/>
+          <p:cNvPr id="6" name="TextBox 5"/>
           <p:cNvSpPr txBox="1"/>
           <p:nvPr/>
         </p:nvSpPr>
@@ -4557,7 +4656,7 @@
               </a:defRPr>
             </a:pPr>
             <a:r>
-              <a:t>Balanced risk/opportunity profile with execution uncertainty</a:t>
+              <a:t>Margin pressure and elevated risks warrant caution; watch for stabilization</a:t>
             </a:r>
           </a:p>
         </p:txBody>
@@ -6531,7 +6630,7 @@
               <a:defRPr sz="1600"/>
             </a:pPr>
             <a:r>
-              <a:t>Balanced risk/opportunity profile with execution uncertainty</a:t>
+              <a:t>Margin pressure and elevated risks warrant caution; watch for stabilization</a:t>
             </a:r>
           </a:p>
         </p:txBody>
@@ -6587,6 +6686,44 @@
               <a:t>22 mentions across 8 periods, avg 2.8/period</a:t>
             </a:r>
           </a:p>
+          <a:p>
+            <a:pPr>
+              <a:defRPr sz="1400" b="1"/>
+            </a:pPr>
+            <a:r>
+              <a:t>Interest Coverage Decline (Medium)</a:t>
+            </a:r>
+          </a:p>
+          <a:p>
+            <a:pPr lvl="1">
+              <a:spcAft>
+                <a:spcPts val="600"/>
+              </a:spcAft>
+              <a:defRPr sz="1200"/>
+            </a:pPr>
+            <a:r>
+              <a:t>Coverage dropped 27% QoQ (11.3x → 8.2x)</a:t>
+            </a:r>
+          </a:p>
+          <a:p>
+            <a:pPr>
+              <a:defRPr sz="1400" b="1"/>
+            </a:pPr>
+            <a:r>
+              <a:t>Margin Compression (High)</a:t>
+            </a:r>
+          </a:p>
+          <a:p>
+            <a:pPr lvl="1">
+              <a:spcAft>
+                <a:spcPts val="600"/>
+              </a:spcAft>
+              <a:defRPr sz="1200"/>
+            </a:pPr>
+            <a:r>
+              <a:t>Operating margin 3.8% vs 7.1% baseline (-3.3pp)</a:t>
+            </a:r>
+          </a:p>
         </p:txBody>
       </p:sp>
       <p:sp>
@@ -6626,7 +6763,7 @@
               <a:defRPr sz="1400" b="1"/>
             </a:pPr>
             <a:r>
-              <a:t>Digital Sales Growth (High potential)</a:t>
+              <a:t>Digital Sales Growth (Medium potential)</a:t>
             </a:r>
           </a:p>
           <a:p>
@@ -6637,7 +6774,7 @@
               <a:defRPr sz="1200"/>
             </a:pPr>
             <a:r>
-              <a:t>Digital comp sales up 2.4% in latest quarter</a:t>
+              <a:t>Digital comp sales 2.4% (slowing from 4.3%)</a:t>
             </a:r>
           </a:p>
         </p:txBody>
@@ -7418,9 +7555,42 @@
           </a:p>
         </p:txBody>
       </p:sp>
+      <p:sp>
+        <p:nvSpPr>
+          <p:cNvPr id="3" name="TextBox 2"/>
+          <p:cNvSpPr txBox="1"/>
+          <p:nvPr/>
+        </p:nvSpPr>
+        <p:spPr>
+          <a:xfrm>
+            <a:off x="8229600" y="228600"/>
+            <a:ext cx="365760" cy="365760"/>
+          </a:xfrm>
+          <a:prstGeom prst="rect">
+            <a:avLst/>
+          </a:prstGeom>
+          <a:noFill/>
+        </p:spPr>
+        <p:txBody>
+          <a:bodyPr wrap="none">
+            <a:spAutoFit/>
+          </a:bodyPr>
+          <a:lstStyle/>
+          <a:p>
+            <a:r>
+              <a:rPr sz="1800">
+                <a:solidFill>
+                  <a:srgbClr val="646464"/>
+                </a:solidFill>
+              </a:rPr>
+              <a:t>ⓘ</a:t>
+            </a:r>
+          </a:p>
+        </p:txBody>
+      </p:sp>
       <p:pic>
         <p:nvPicPr>
-          <p:cNvPr id="3" name="Picture 2" descr="chart_revenue_vs_inventory.png"/>
+          <p:cNvPr id="4" name="Picture 3" descr="chart_revenue_vs_inventory.png"/>
           <p:cNvPicPr>
             <a:picLocks noChangeAspect="1"/>
           </p:cNvPicPr>
@@ -7444,7 +7614,7 @@
       </p:pic>
       <p:sp>
         <p:nvSpPr>
-          <p:cNvPr id="4" name="TextBox 3"/>
+          <p:cNvPr id="5" name="TextBox 4"/>
           <p:cNvSpPr txBox="1"/>
           <p:nvPr/>
         </p:nvSpPr>
@@ -7465,9 +7635,9 @@
           <a:lstStyle/>
           <a:p>
             <a:pPr>
-              <a:defRPr sz="1200">
-                <a:solidFill>
-                  <a:srgbClr val="646464"/>
+              <a:defRPr sz="1200" b="1">
+                <a:solidFill>
+                  <a:srgbClr val="323232"/>
                 </a:solidFill>
               </a:defRPr>
             </a:pPr>
@@ -7479,7 +7649,7 @@
       </p:sp>
       <p:sp>
         <p:nvSpPr>
-          <p:cNvPr id="5" name="TextBox 4"/>
+          <p:cNvPr id="6" name="TextBox 5"/>
           <p:cNvSpPr txBox="1"/>
           <p:nvPr/>
         </p:nvSpPr>
@@ -7564,9 +7734,42 @@
           </a:p>
         </p:txBody>
       </p:sp>
+      <p:sp>
+        <p:nvSpPr>
+          <p:cNvPr id="3" name="TextBox 2"/>
+          <p:cNvSpPr txBox="1"/>
+          <p:nvPr/>
+        </p:nvSpPr>
+        <p:spPr>
+          <a:xfrm>
+            <a:off x="8229600" y="228600"/>
+            <a:ext cx="365760" cy="365760"/>
+          </a:xfrm>
+          <a:prstGeom prst="rect">
+            <a:avLst/>
+          </a:prstGeom>
+          <a:noFill/>
+        </p:spPr>
+        <p:txBody>
+          <a:bodyPr wrap="none">
+            <a:spAutoFit/>
+          </a:bodyPr>
+          <a:lstStyle/>
+          <a:p>
+            <a:r>
+              <a:rPr sz="1800">
+                <a:solidFill>
+                  <a:srgbClr val="646464"/>
+                </a:solidFill>
+              </a:rPr>
+              <a:t>ⓘ</a:t>
+            </a:r>
+          </a:p>
+        </p:txBody>
+      </p:sp>
       <p:pic>
         <p:nvPicPr>
-          <p:cNvPr id="3" name="Picture 2" descr="chart_margin_analysis.png"/>
+          <p:cNvPr id="4" name="Picture 3" descr="chart_margin_analysis.png"/>
           <p:cNvPicPr>
             <a:picLocks noChangeAspect="1"/>
           </p:cNvPicPr>
@@ -7590,7 +7793,7 @@
       </p:pic>
       <p:sp>
         <p:nvSpPr>
-          <p:cNvPr id="4" name="TextBox 3"/>
+          <p:cNvPr id="5" name="TextBox 4"/>
           <p:cNvSpPr txBox="1"/>
           <p:nvPr/>
         </p:nvSpPr>
@@ -7611,9 +7814,9 @@
           <a:lstStyle/>
           <a:p>
             <a:pPr>
-              <a:defRPr sz="1200">
-                <a:solidFill>
-                  <a:srgbClr val="646464"/>
+              <a:defRPr sz="1200" b="1">
+                <a:solidFill>
+                  <a:srgbClr val="323232"/>
                 </a:solidFill>
               </a:defRPr>
             </a:pPr>
@@ -7625,7 +7828,7 @@
       </p:sp>
       <p:sp>
         <p:nvSpPr>
-          <p:cNvPr id="5" name="TextBox 4"/>
+          <p:cNvPr id="6" name="TextBox 5"/>
           <p:cNvSpPr txBox="1"/>
           <p:nvPr/>
         </p:nvSpPr>
@@ -8278,9 +8481,42 @@
           </a:p>
         </p:txBody>
       </p:sp>
+      <p:sp>
+        <p:nvSpPr>
+          <p:cNvPr id="3" name="TextBox 2"/>
+          <p:cNvSpPr txBox="1"/>
+          <p:nvPr/>
+        </p:nvSpPr>
+        <p:spPr>
+          <a:xfrm>
+            <a:off x="8229600" y="228600"/>
+            <a:ext cx="365760" cy="365760"/>
+          </a:xfrm>
+          <a:prstGeom prst="rect">
+            <a:avLst/>
+          </a:prstGeom>
+          <a:noFill/>
+        </p:spPr>
+        <p:txBody>
+          <a:bodyPr wrap="none">
+            <a:spAutoFit/>
+          </a:bodyPr>
+          <a:lstStyle/>
+          <a:p>
+            <a:r>
+              <a:rPr sz="1800">
+                <a:solidFill>
+                  <a:srgbClr val="646464"/>
+                </a:solidFill>
+              </a:rPr>
+              <a:t>ⓘ</a:t>
+            </a:r>
+          </a:p>
+        </p:txBody>
+      </p:sp>
       <p:pic>
         <p:nvPicPr>
-          <p:cNvPr id="3" name="Picture 2" descr="chart_debt_health.png"/>
+          <p:cNvPr id="4" name="Picture 3" descr="chart_debt_health.png"/>
           <p:cNvPicPr>
             <a:picLocks noChangeAspect="1"/>
           </p:cNvPicPr>
@@ -8304,7 +8540,7 @@
       </p:pic>
       <p:sp>
         <p:nvSpPr>
-          <p:cNvPr id="4" name="TextBox 3"/>
+          <p:cNvPr id="5" name="TextBox 4"/>
           <p:cNvSpPr txBox="1"/>
           <p:nvPr/>
         </p:nvSpPr>
@@ -8325,9 +8561,9 @@
           <a:lstStyle/>
           <a:p>
             <a:pPr>
-              <a:defRPr sz="1200">
-                <a:solidFill>
-                  <a:srgbClr val="646464"/>
+              <a:defRPr sz="1200" b="1">
+                <a:solidFill>
+                  <a:srgbClr val="323232"/>
                 </a:solidFill>
               </a:defRPr>
             </a:pPr>
@@ -8339,7 +8575,7 @@
       </p:sp>
       <p:sp>
         <p:nvSpPr>
-          <p:cNvPr id="5" name="TextBox 4"/>
+          <p:cNvPr id="6" name="TextBox 5"/>
           <p:cNvSpPr txBox="1"/>
           <p:nvPr/>
         </p:nvSpPr>

</xml_diff>